<commit_message>
Correct hackathon name across the submission material
The README on main names the Bano Qabil AI hackathon; the original brief this
work was built from said the Alibaba Cloud "AI For Pakistan Future" hackathon.
Taking the README as authoritative and updating the deck, the written project
description, and the implementation plan to match, with author credit on the
title slide.

Note this may also invalidate an assumption in docs/deployment.md, which
treats deployment on Alibaba Cloud as a submission requirement. Qwen still
runs on Alibaba DashScope either way, so deploying there remains coherent, but
whether it is required is now an open question.
</commit_message>
<xml_diff>
--- a/docs/deck.pptx
+++ b/docs/deck.pptx
@@ -3137,7 +3137,7 @@
                 </a:solidFill>
                 <a:latin typeface="IBM Plex Mono"/>
               </a:rPr>
-              <a:t>AI FOR PAKISTAN FUTURE</a:t>
+              <a:t>BANO QABIL AI HACKATHON</a:t>
             </a:r>
           </a:p>
         </p:txBody>
@@ -3321,7 +3321,7 @@
                 </a:solidFill>
                 <a:latin typeface="IBM Plex Mono"/>
               </a:rPr>
-              <a:t>Alibaba Cloud hackathon · LightGBM + SHAP + Qwen</a:t>
+              <a:t>Mirza Ahsan Baig and Safee · LightGBM + SHAP + Qwen on DashScope</a:t>
             </a:r>
           </a:p>
         </p:txBody>

</xml_diff>

<commit_message>
Correct the deployment claim and add an interface slide
The description and the deck both said the system is "deployed on Alibaba
Cloud ECS". It is not, and was never going to be before the deadline — both
services are containerised and deployment.md is a tested runbook, which is
what they now say. A judge asking for the live URL should not find the
submission overstating itself.

The deck had eight slides and none of them showed what the thing does. Adds
one on the interface: the estimate visible from the first question, answers
scored against the reading before them, and no reason code invented for a
clean claim.
</commit_message>
<xml_diff>
--- a/docs/deck.pptx
+++ b/docs/deck.pptx
@@ -13,6 +13,7 @@
     <p:sldId id="261" r:id="rId12"/>
     <p:sldId id="262" r:id="rId13"/>
     <p:sldId id="263" r:id="rId14"/>
+    <p:sldId id="264" r:id="rId15"/>
   </p:sldIdLst>
   <p:sldSz cx="12191695" cy="6858000" type="screen4x3"/>
   <p:notesSz cx="6858000" cy="9144000"/>
@@ -4640,7 +4641,7 @@
                 </a:solidFill>
                 <a:latin typeface="IBM Plex Mono"/>
               </a:rPr>
-              <a:t>RESULTS</a:t>
+              <a:t>THE INTERFACE</a:t>
             </a:r>
           </a:p>
         </p:txBody>
@@ -4679,7 +4680,7 @@
                 </a:solidFill>
                 <a:latin typeface="Newsreader"/>
               </a:rPr>
-              <a:t>Deliberately not perfect</a:t>
+              <a:t>The estimate is never hidden</a:t>
             </a:r>
           </a:p>
         </p:txBody>
@@ -4753,7 +4754,7 @@
                 </a:solidFill>
                 <a:latin typeface="IBM Plex Sans"/>
               </a:rPr>
-              <a:t>Only 26.5% of claims are rejected, so blindly approving everything</a:t>
+              <a:t>The running probability is on screen from the first question, so there</a:t>
             </a:r>
           </a:p>
           <a:p>
@@ -4769,7 +4770,7 @@
                 </a:solidFill>
                 <a:latin typeface="IBM Plex Sans"/>
               </a:rPr>
-              <a:t>already scores 73.5%. Accuracy is the wrong headline — AUC and recall</a:t>
+              <a:t>is no reveal to wait for. Every answer is scored against the reading</a:t>
             </a:r>
           </a:p>
           <a:p>
@@ -4785,15 +4786,8 @@
                 </a:solidFill>
                 <a:latin typeface="IBM Plex Sans"/>
               </a:rPr>
-              <a:t>are the meaningful numbers.</a:t>
-            </a:r>
-          </a:p>
-          <a:p>
-            <a:pPr>
-              <a:spcAft>
-                <a:spcPts val="300"/>
-              </a:spcAft>
-            </a:pPr>
+              <a:t>immediately before it — a field that hurts the claim is flagged while</a:t>
+            </a:r>
           </a:p>
           <a:p>
             <a:pPr>
@@ -4808,8 +4802,15 @@
                 </a:solidFill>
                 <a:latin typeface="IBM Plex Sans"/>
               </a:rPr>
-              <a:t>Per-code accuracy is highest where it matters: 92% on CARC 197,</a:t>
-            </a:r>
+              <a:t>staff can still correct it, not in the verdict when they cannot.</a:t>
+            </a:r>
+          </a:p>
+          <a:p>
+            <a:pPr>
+              <a:spcAft>
+                <a:spcPts val="300"/>
+              </a:spcAft>
+            </a:pPr>
           </a:p>
           <a:p>
             <a:pPr>
@@ -4824,7 +4825,94 @@
                 </a:solidFill>
                 <a:latin typeface="IBM Plex Sans"/>
               </a:rPr>
-              <a:t>pre-authorisation absent.</a:t>
+              <a:t>     "Supporting documents: Some missing — this raised the</a:t>
+            </a:r>
+          </a:p>
+          <a:p>
+            <a:pPr>
+              <a:spcAft>
+                <a:spcPts val="300"/>
+              </a:spcAft>
+            </a:pPr>
+            <a:r>
+              <a:rPr sz="1500">
+                <a:solidFill>
+                  <a:srgbClr val="4A463B"/>
+                </a:solidFill>
+                <a:latin typeface="IBM Plex Sans"/>
+              </a:rPr>
+              <a:t>      estimate by 17 points."</a:t>
+            </a:r>
+          </a:p>
+          <a:p>
+            <a:pPr>
+              <a:spcAft>
+                <a:spcPts val="300"/>
+              </a:spcAft>
+            </a:pPr>
+          </a:p>
+          <a:p>
+            <a:pPr>
+              <a:spcAft>
+                <a:spcPts val="300"/>
+              </a:spcAft>
+            </a:pPr>
+            <a:r>
+              <a:rPr sz="1500">
+                <a:solidFill>
+                  <a:srgbClr val="4A463B"/>
+                </a:solidFill>
+                <a:latin typeface="IBM Plex Sans"/>
+              </a:rPr>
+              <a:t>SHAP attribution, the CARC citation and Qwen's plain-language reading</a:t>
+            </a:r>
+          </a:p>
+          <a:p>
+            <a:pPr>
+              <a:spcAft>
+                <a:spcPts val="300"/>
+              </a:spcAft>
+            </a:pPr>
+            <a:r>
+              <a:rPr sz="1500">
+                <a:solidFill>
+                  <a:srgbClr val="4A463B"/>
+                </a:solidFill>
+                <a:latin typeface="IBM Plex Sans"/>
+              </a:rPr>
+              <a:t>sit alongside it. No rejection reason is shown for a clean claim: the</a:t>
+            </a:r>
+          </a:p>
+          <a:p>
+            <a:pPr>
+              <a:spcAft>
+                <a:spcPts val="300"/>
+              </a:spcAft>
+            </a:pPr>
+            <a:r>
+              <a:rPr sz="1500">
+                <a:solidFill>
+                  <a:srgbClr val="4A463B"/>
+                </a:solidFill>
+                <a:latin typeface="IBM Plex Sans"/>
+              </a:rPr>
+              <a:t>reason model trains only on rejected claims, so naming one would be</a:t>
+            </a:r>
+          </a:p>
+          <a:p>
+            <a:pPr>
+              <a:spcAft>
+                <a:spcPts val="300"/>
+              </a:spcAft>
+            </a:pPr>
+            <a:r>
+              <a:rPr sz="1500">
+                <a:solidFill>
+                  <a:srgbClr val="4A463B"/>
+                </a:solidFill>
+                <a:latin typeface="IBM Plex Sans"/>
+              </a:rPr>
+              <a:t>inventing a problem.</a:t>
             </a:r>
           </a:p>
         </p:txBody>
@@ -4837,8 +4925,8 @@
         </p:nvSpPr>
         <p:spPr>
           <a:xfrm>
-            <a:off x="8229600" y="2377440"/>
-            <a:ext cx="3108960" cy="640080"/>
+            <a:off x="822960" y="6035040"/>
+            <a:ext cx="10515600" cy="365760"/>
           </a:xfrm>
           <a:prstGeom prst="rect">
             <a:avLst/>
@@ -4857,13 +4945,13 @@
               </a:spcAft>
             </a:pPr>
             <a:r>
-              <a:rPr sz="3400" b="0">
-                <a:solidFill>
-                  <a:srgbClr val="1F4B43"/>
-                </a:solidFill>
-                <a:latin typeface="Newsreader"/>
-              </a:rPr>
-              <a:t>0.788</a:t>
+              <a:rPr sz="1100" b="0">
+                <a:solidFill>
+                  <a:srgbClr val="7D7767"/>
+                </a:solidFill>
+                <a:latin typeface="IBM Plex Mono"/>
+              </a:rPr>
+              <a:t>Built for clinic admin staff — CARC, SHAP and information gain each carry a definition</a:t>
             </a:r>
           </a:p>
         </p:txBody>
@@ -4871,240 +4959,6 @@
       <p:sp>
         <p:nvSpPr>
           <p:cNvPr id="7" name="TextBox 6"/>
-          <p:cNvSpPr txBox="1"/>
-          <p:nvPr/>
-        </p:nvSpPr>
-        <p:spPr>
-          <a:xfrm>
-            <a:off x="8275320" y="2944368"/>
-            <a:ext cx="3108960" cy="365760"/>
-          </a:xfrm>
-          <a:prstGeom prst="rect">
-            <a:avLst/>
-          </a:prstGeom>
-          <a:noFill/>
-        </p:spPr>
-        <p:txBody>
-          <a:bodyPr wrap="none">
-            <a:spAutoFit/>
-          </a:bodyPr>
-          <a:lstStyle/>
-          <a:p>
-            <a:pPr algn="l">
-              <a:spcAft>
-                <a:spcPts val="0"/>
-              </a:spcAft>
-            </a:pPr>
-            <a:r>
-              <a:rPr sz="1100" b="0">
-                <a:solidFill>
-                  <a:srgbClr val="7D7767"/>
-                </a:solidFill>
-                <a:latin typeface="IBM Plex Mono"/>
-              </a:rPr>
-              <a:t>ROC AUC</a:t>
-            </a:r>
-          </a:p>
-        </p:txBody>
-      </p:sp>
-      <p:sp>
-        <p:nvSpPr>
-          <p:cNvPr id="8" name="TextBox 7"/>
-          <p:cNvSpPr txBox="1"/>
-          <p:nvPr/>
-        </p:nvSpPr>
-        <p:spPr>
-          <a:xfrm>
-            <a:off x="8229600" y="3611880"/>
-            <a:ext cx="3108960" cy="640080"/>
-          </a:xfrm>
-          <a:prstGeom prst="rect">
-            <a:avLst/>
-          </a:prstGeom>
-          <a:noFill/>
-        </p:spPr>
-        <p:txBody>
-          <a:bodyPr wrap="none">
-            <a:spAutoFit/>
-          </a:bodyPr>
-          <a:lstStyle/>
-          <a:p>
-            <a:pPr algn="l">
-              <a:spcAft>
-                <a:spcPts val="0"/>
-              </a:spcAft>
-            </a:pPr>
-            <a:r>
-              <a:rPr sz="3400" b="0">
-                <a:solidFill>
-                  <a:srgbClr val="1F4B43"/>
-                </a:solidFill>
-                <a:latin typeface="Newsreader"/>
-              </a:rPr>
-              <a:t>67.7%</a:t>
-            </a:r>
-          </a:p>
-        </p:txBody>
-      </p:sp>
-      <p:sp>
-        <p:nvSpPr>
-          <p:cNvPr id="9" name="TextBox 8"/>
-          <p:cNvSpPr txBox="1"/>
-          <p:nvPr/>
-        </p:nvSpPr>
-        <p:spPr>
-          <a:xfrm>
-            <a:off x="8275320" y="4178808"/>
-            <a:ext cx="3108960" cy="365760"/>
-          </a:xfrm>
-          <a:prstGeom prst="rect">
-            <a:avLst/>
-          </a:prstGeom>
-          <a:noFill/>
-        </p:spPr>
-        <p:txBody>
-          <a:bodyPr wrap="none">
-            <a:spAutoFit/>
-          </a:bodyPr>
-          <a:lstStyle/>
-          <a:p>
-            <a:pPr algn="l">
-              <a:spcAft>
-                <a:spcPts val="0"/>
-              </a:spcAft>
-            </a:pPr>
-            <a:r>
-              <a:rPr sz="1100" b="0">
-                <a:solidFill>
-                  <a:srgbClr val="7D7767"/>
-                </a:solidFill>
-                <a:latin typeface="IBM Plex Mono"/>
-              </a:rPr>
-              <a:t>recall</a:t>
-            </a:r>
-          </a:p>
-        </p:txBody>
-      </p:sp>
-      <p:sp>
-        <p:nvSpPr>
-          <p:cNvPr id="10" name="TextBox 9"/>
-          <p:cNvSpPr txBox="1"/>
-          <p:nvPr/>
-        </p:nvSpPr>
-        <p:spPr>
-          <a:xfrm>
-            <a:off x="8229600" y="4846320"/>
-            <a:ext cx="3108960" cy="640080"/>
-          </a:xfrm>
-          <a:prstGeom prst="rect">
-            <a:avLst/>
-          </a:prstGeom>
-          <a:noFill/>
-        </p:spPr>
-        <p:txBody>
-          <a:bodyPr wrap="none">
-            <a:spAutoFit/>
-          </a:bodyPr>
-          <a:lstStyle/>
-          <a:p>
-            <a:pPr algn="l">
-              <a:spcAft>
-                <a:spcPts val="0"/>
-              </a:spcAft>
-            </a:pPr>
-            <a:r>
-              <a:rPr sz="3400" b="0">
-                <a:solidFill>
-                  <a:srgbClr val="1F4B43"/>
-                </a:solidFill>
-                <a:latin typeface="Newsreader"/>
-              </a:rPr>
-              <a:t>68 / 80%</a:t>
-            </a:r>
-          </a:p>
-        </p:txBody>
-      </p:sp>
-      <p:sp>
-        <p:nvSpPr>
-          <p:cNvPr id="11" name="TextBox 10"/>
-          <p:cNvSpPr txBox="1"/>
-          <p:nvPr/>
-        </p:nvSpPr>
-        <p:spPr>
-          <a:xfrm>
-            <a:off x="8275320" y="5413248"/>
-            <a:ext cx="3108960" cy="365760"/>
-          </a:xfrm>
-          <a:prstGeom prst="rect">
-            <a:avLst/>
-          </a:prstGeom>
-          <a:noFill/>
-        </p:spPr>
-        <p:txBody>
-          <a:bodyPr wrap="none">
-            <a:spAutoFit/>
-          </a:bodyPr>
-          <a:lstStyle/>
-          <a:p>
-            <a:pPr algn="l">
-              <a:spcAft>
-                <a:spcPts val="0"/>
-              </a:spcAft>
-            </a:pPr>
-            <a:r>
-              <a:rPr sz="1100" b="0">
-                <a:solidFill>
-                  <a:srgbClr val="7D7767"/>
-                </a:solidFill>
-                <a:latin typeface="IBM Plex Mono"/>
-              </a:rPr>
-              <a:t>CARC top-1 / top-3</a:t>
-            </a:r>
-          </a:p>
-        </p:txBody>
-      </p:sp>
-      <p:sp>
-        <p:nvSpPr>
-          <p:cNvPr id="12" name="TextBox 11"/>
-          <p:cNvSpPr txBox="1"/>
-          <p:nvPr/>
-        </p:nvSpPr>
-        <p:spPr>
-          <a:xfrm>
-            <a:off x="822960" y="6035040"/>
-            <a:ext cx="10515600" cy="365760"/>
-          </a:xfrm>
-          <a:prstGeom prst="rect">
-            <a:avLst/>
-          </a:prstGeom>
-          <a:noFill/>
-        </p:spPr>
-        <p:txBody>
-          <a:bodyPr wrap="none">
-            <a:spAutoFit/>
-          </a:bodyPr>
-          <a:lstStyle/>
-          <a:p>
-            <a:pPr algn="l">
-              <a:spcAft>
-                <a:spcPts val="0"/>
-              </a:spcAft>
-            </a:pPr>
-            <a:r>
-              <a:rPr sz="1100" b="0">
-                <a:solidFill>
-                  <a:srgbClr val="7D7767"/>
-                </a:solidFill>
-                <a:latin typeface="IBM Plex Mono"/>
-              </a:rPr>
-              <a:t>Held at 77.9% accuracy on purpose — see next slide</a:t>
-            </a:r>
-          </a:p>
-        </p:txBody>
-      </p:sp>
-      <p:sp>
-        <p:nvSpPr>
-          <p:cNvPr id="13" name="TextBox 12"/>
           <p:cNvSpPr txBox="1"/>
           <p:nvPr/>
         </p:nvSpPr>
@@ -5201,7 +5055,7 @@
                 </a:solidFill>
                 <a:latin typeface="IBM Plex Mono"/>
               </a:rPr>
-              <a:t>THE DATA</a:t>
+              <a:t>RESULTS</a:t>
             </a:r>
           </a:p>
         </p:txBody>
@@ -5240,7 +5094,7 @@
                 </a:solidFill>
                 <a:latin typeface="Newsreader"/>
               </a:rPr>
-              <a:t>No, the data is not real. It cannot be.</a:t>
+              <a:t>Deliberately not perfect</a:t>
             </a:r>
           </a:p>
         </p:txBody>
@@ -5314,7 +5168,7 @@
                 </a:solidFill>
                 <a:latin typeface="IBM Plex Sans"/>
               </a:rPr>
-              <a:t>No public dataset exists anywhere of real clinic claims paired with</a:t>
+              <a:t>Only 26.5% of claims are rejected, so blindly approving everything</a:t>
             </a:r>
           </a:p>
           <a:p>
@@ -5330,7 +5184,7 @@
                 </a:solidFill>
                 <a:latin typeface="IBM Plex Sans"/>
               </a:rPr>
-              <a:t>their outcomes. Insurers treat that as private business information.</a:t>
+              <a:t>already scores 73.5%. Accuracy is the wrong headline — AUC and recall</a:t>
             </a:r>
           </a:p>
           <a:p>
@@ -5346,7 +5200,7 @@
                 </a:solidFill>
                 <a:latin typeface="IBM Plex Sans"/>
               </a:rPr>
-              <a:t>Every commercial product here trains on its own private history.</a:t>
+              <a:t>are the meaningful numbers.</a:t>
             </a:r>
           </a:p>
           <a:p>
@@ -5369,7 +5223,7 @@
                 </a:solidFill>
                 <a:latin typeface="IBM Plex Sans"/>
               </a:rPr>
-              <a:t>So we built ours from two real pieces:</a:t>
+              <a:t>Per-code accuracy is highest where it matters: 92% on CARC 197,</a:t>
             </a:r>
           </a:p>
           <a:p>
@@ -5385,78 +5239,7 @@
                 </a:solidFill>
                 <a:latin typeface="IBM Plex Sans"/>
               </a:rPr>
-              <a:t>     Synthea — open clinical simulator, real SNOMED CT codes</a:t>
-            </a:r>
-          </a:p>
-          <a:p>
-            <a:pPr>
-              <a:spcAft>
-                <a:spcPts val="300"/>
-              </a:spcAft>
-            </a:pPr>
-            <a:r>
-              <a:rPr sz="1500">
-                <a:solidFill>
-                  <a:srgbClr val="4A463B"/>
-                </a:solidFill>
-                <a:latin typeface="IBM Plex Sans"/>
-              </a:rPr>
-              <a:t>     X12 CARC — the real industry rejection-reason standard</a:t>
-            </a:r>
-          </a:p>
-          <a:p>
-            <a:pPr>
-              <a:spcAft>
-                <a:spcPts val="300"/>
-              </a:spcAft>
-            </a:pPr>
-          </a:p>
-          <a:p>
-            <a:pPr>
-              <a:spcAft>
-                <a:spcPts val="300"/>
-              </a:spcAft>
-            </a:pPr>
-            <a:r>
-              <a:rPr sz="1500">
-                <a:solidFill>
-                  <a:srgbClr val="4A463B"/>
-                </a:solidFill>
-                <a:latin typeface="IBM Plex Sans"/>
-              </a:rPr>
-              <a:t>Only the labelling logic is ours, and we documented exactly where</a:t>
-            </a:r>
-          </a:p>
-          <a:p>
-            <a:pPr>
-              <a:spcAft>
-                <a:spcPts val="300"/>
-              </a:spcAft>
-            </a:pPr>
-            <a:r>
-              <a:rPr sz="1500">
-                <a:solidFill>
-                  <a:srgbClr val="4A463B"/>
-                </a:solidFill>
-                <a:latin typeface="IBM Plex Sans"/>
-              </a:rPr>
-              <a:t>that line falls. A near-perfect score on self-generated data would</a:t>
-            </a:r>
-          </a:p>
-          <a:p>
-            <a:pPr>
-              <a:spcAft>
-                <a:spcPts val="300"/>
-              </a:spcAft>
-            </a:pPr>
-            <a:r>
-              <a:rPr sz="1500">
-                <a:solidFill>
-                  <a:srgbClr val="4A463B"/>
-                </a:solidFill>
-                <a:latin typeface="IBM Plex Sans"/>
-              </a:rPr>
-              <a:t>only prove the model memorised our own rules.</a:t>
+              <a:t>pre-authorisation absent.</a:t>
             </a:r>
           </a:p>
         </p:txBody>
@@ -5469,8 +5252,8 @@
         </p:nvSpPr>
         <p:spPr>
           <a:xfrm>
-            <a:off x="822960" y="6035040"/>
-            <a:ext cx="10515600" cy="365760"/>
+            <a:off x="8229600" y="2377440"/>
+            <a:ext cx="3108960" cy="640080"/>
           </a:xfrm>
           <a:prstGeom prst="rect">
             <a:avLst/>
@@ -5489,20 +5272,254 @@
               </a:spcAft>
             </a:pPr>
             <a:r>
+              <a:rPr sz="3400" b="0">
+                <a:solidFill>
+                  <a:srgbClr val="1F4B43"/>
+                </a:solidFill>
+                <a:latin typeface="Newsreader"/>
+              </a:rPr>
+              <a:t>0.788</a:t>
+            </a:r>
+          </a:p>
+        </p:txBody>
+      </p:sp>
+      <p:sp>
+        <p:nvSpPr>
+          <p:cNvPr id="7" name="TextBox 6"/>
+          <p:cNvSpPr txBox="1"/>
+          <p:nvPr/>
+        </p:nvSpPr>
+        <p:spPr>
+          <a:xfrm>
+            <a:off x="8275320" y="2944368"/>
+            <a:ext cx="3108960" cy="365760"/>
+          </a:xfrm>
+          <a:prstGeom prst="rect">
+            <a:avLst/>
+          </a:prstGeom>
+          <a:noFill/>
+        </p:spPr>
+        <p:txBody>
+          <a:bodyPr wrap="none">
+            <a:spAutoFit/>
+          </a:bodyPr>
+          <a:lstStyle/>
+          <a:p>
+            <a:pPr algn="l">
+              <a:spcAft>
+                <a:spcPts val="0"/>
+              </a:spcAft>
+            </a:pPr>
+            <a:r>
               <a:rPr sz="1100" b="0">
                 <a:solidFill>
                   <a:srgbClr val="7D7767"/>
                 </a:solidFill>
                 <a:latin typeface="IBM Plex Mono"/>
               </a:rPr>
-              <a:t>docs/data-provenance.md · docs/model-card.md</a:t>
-            </a:r>
-          </a:p>
-        </p:txBody>
-      </p:sp>
-      <p:sp>
-        <p:nvSpPr>
-          <p:cNvPr id="7" name="TextBox 6"/>
+              <a:t>ROC AUC</a:t>
+            </a:r>
+          </a:p>
+        </p:txBody>
+      </p:sp>
+      <p:sp>
+        <p:nvSpPr>
+          <p:cNvPr id="8" name="TextBox 7"/>
+          <p:cNvSpPr txBox="1"/>
+          <p:nvPr/>
+        </p:nvSpPr>
+        <p:spPr>
+          <a:xfrm>
+            <a:off x="8229600" y="3611880"/>
+            <a:ext cx="3108960" cy="640080"/>
+          </a:xfrm>
+          <a:prstGeom prst="rect">
+            <a:avLst/>
+          </a:prstGeom>
+          <a:noFill/>
+        </p:spPr>
+        <p:txBody>
+          <a:bodyPr wrap="none">
+            <a:spAutoFit/>
+          </a:bodyPr>
+          <a:lstStyle/>
+          <a:p>
+            <a:pPr algn="l">
+              <a:spcAft>
+                <a:spcPts val="0"/>
+              </a:spcAft>
+            </a:pPr>
+            <a:r>
+              <a:rPr sz="3400" b="0">
+                <a:solidFill>
+                  <a:srgbClr val="1F4B43"/>
+                </a:solidFill>
+                <a:latin typeface="Newsreader"/>
+              </a:rPr>
+              <a:t>67.7%</a:t>
+            </a:r>
+          </a:p>
+        </p:txBody>
+      </p:sp>
+      <p:sp>
+        <p:nvSpPr>
+          <p:cNvPr id="9" name="TextBox 8"/>
+          <p:cNvSpPr txBox="1"/>
+          <p:nvPr/>
+        </p:nvSpPr>
+        <p:spPr>
+          <a:xfrm>
+            <a:off x="8275320" y="4178808"/>
+            <a:ext cx="3108960" cy="365760"/>
+          </a:xfrm>
+          <a:prstGeom prst="rect">
+            <a:avLst/>
+          </a:prstGeom>
+          <a:noFill/>
+        </p:spPr>
+        <p:txBody>
+          <a:bodyPr wrap="none">
+            <a:spAutoFit/>
+          </a:bodyPr>
+          <a:lstStyle/>
+          <a:p>
+            <a:pPr algn="l">
+              <a:spcAft>
+                <a:spcPts val="0"/>
+              </a:spcAft>
+            </a:pPr>
+            <a:r>
+              <a:rPr sz="1100" b="0">
+                <a:solidFill>
+                  <a:srgbClr val="7D7767"/>
+                </a:solidFill>
+                <a:latin typeface="IBM Plex Mono"/>
+              </a:rPr>
+              <a:t>recall</a:t>
+            </a:r>
+          </a:p>
+        </p:txBody>
+      </p:sp>
+      <p:sp>
+        <p:nvSpPr>
+          <p:cNvPr id="10" name="TextBox 9"/>
+          <p:cNvSpPr txBox="1"/>
+          <p:nvPr/>
+        </p:nvSpPr>
+        <p:spPr>
+          <a:xfrm>
+            <a:off x="8229600" y="4846320"/>
+            <a:ext cx="3108960" cy="640080"/>
+          </a:xfrm>
+          <a:prstGeom prst="rect">
+            <a:avLst/>
+          </a:prstGeom>
+          <a:noFill/>
+        </p:spPr>
+        <p:txBody>
+          <a:bodyPr wrap="none">
+            <a:spAutoFit/>
+          </a:bodyPr>
+          <a:lstStyle/>
+          <a:p>
+            <a:pPr algn="l">
+              <a:spcAft>
+                <a:spcPts val="0"/>
+              </a:spcAft>
+            </a:pPr>
+            <a:r>
+              <a:rPr sz="3400" b="0">
+                <a:solidFill>
+                  <a:srgbClr val="1F4B43"/>
+                </a:solidFill>
+                <a:latin typeface="Newsreader"/>
+              </a:rPr>
+              <a:t>68 / 80%</a:t>
+            </a:r>
+          </a:p>
+        </p:txBody>
+      </p:sp>
+      <p:sp>
+        <p:nvSpPr>
+          <p:cNvPr id="11" name="TextBox 10"/>
+          <p:cNvSpPr txBox="1"/>
+          <p:nvPr/>
+        </p:nvSpPr>
+        <p:spPr>
+          <a:xfrm>
+            <a:off x="8275320" y="5413248"/>
+            <a:ext cx="3108960" cy="365760"/>
+          </a:xfrm>
+          <a:prstGeom prst="rect">
+            <a:avLst/>
+          </a:prstGeom>
+          <a:noFill/>
+        </p:spPr>
+        <p:txBody>
+          <a:bodyPr wrap="none">
+            <a:spAutoFit/>
+          </a:bodyPr>
+          <a:lstStyle/>
+          <a:p>
+            <a:pPr algn="l">
+              <a:spcAft>
+                <a:spcPts val="0"/>
+              </a:spcAft>
+            </a:pPr>
+            <a:r>
+              <a:rPr sz="1100" b="0">
+                <a:solidFill>
+                  <a:srgbClr val="7D7767"/>
+                </a:solidFill>
+                <a:latin typeface="IBM Plex Mono"/>
+              </a:rPr>
+              <a:t>CARC top-1 / top-3</a:t>
+            </a:r>
+          </a:p>
+        </p:txBody>
+      </p:sp>
+      <p:sp>
+        <p:nvSpPr>
+          <p:cNvPr id="12" name="TextBox 11"/>
+          <p:cNvSpPr txBox="1"/>
+          <p:nvPr/>
+        </p:nvSpPr>
+        <p:spPr>
+          <a:xfrm>
+            <a:off x="822960" y="6035040"/>
+            <a:ext cx="10515600" cy="365760"/>
+          </a:xfrm>
+          <a:prstGeom prst="rect">
+            <a:avLst/>
+          </a:prstGeom>
+          <a:noFill/>
+        </p:spPr>
+        <p:txBody>
+          <a:bodyPr wrap="none">
+            <a:spAutoFit/>
+          </a:bodyPr>
+          <a:lstStyle/>
+          <a:p>
+            <a:pPr algn="l">
+              <a:spcAft>
+                <a:spcPts val="0"/>
+              </a:spcAft>
+            </a:pPr>
+            <a:r>
+              <a:rPr sz="1100" b="0">
+                <a:solidFill>
+                  <a:srgbClr val="7D7767"/>
+                </a:solidFill>
+                <a:latin typeface="IBM Plex Mono"/>
+              </a:rPr>
+              <a:t>Held at 77.9% accuracy on purpose — see next slide</a:t>
+            </a:r>
+          </a:p>
+        </p:txBody>
+      </p:sp>
+      <p:sp>
+        <p:nvSpPr>
+          <p:cNvPr id="13" name="TextBox 12"/>
           <p:cNvSpPr txBox="1"/>
           <p:nvPr/>
         </p:nvSpPr>
@@ -5599,7 +5616,7 @@
                 </a:solidFill>
                 <a:latin typeface="IBM Plex Mono"/>
               </a:rPr>
-              <a:t>THE LOOP</a:t>
+              <a:t>THE DATA</a:t>
             </a:r>
           </a:p>
         </p:txBody>
@@ -5638,7 +5655,7 @@
                 </a:solidFill>
                 <a:latin typeface="Newsreader"/>
               </a:rPr>
-              <a:t>Honest about self-improvement</a:t>
+              <a:t>No, the data is not real. It cannot be.</a:t>
             </a:r>
           </a:p>
         </p:txBody>
@@ -5712,7 +5729,7 @@
                 </a:solidFill>
                 <a:latin typeface="IBM Plex Sans"/>
               </a:rPr>
-              <a:t>When staff disagree, one click logs the correction as a labelled</a:t>
+              <a:t>No public dataset exists anywhere of real clinic claims paired with</a:t>
             </a:r>
           </a:p>
           <a:p>
@@ -5728,15 +5745,8 @@
                 </a:solidFill>
                 <a:latin typeface="IBM Plex Sans"/>
               </a:rPr>
-              <a:t>example. That is all it does, and we say so.</a:t>
-            </a:r>
-          </a:p>
-          <a:p>
-            <a:pPr>
-              <a:spcAft>
-                <a:spcPts val="300"/>
-              </a:spcAft>
-            </a:pPr>
+              <a:t>their outcomes. Insurers treat that as private business information.</a:t>
+            </a:r>
           </a:p>
           <a:p>
             <a:pPr>
@@ -5751,8 +5761,15 @@
                 </a:solidFill>
                 <a:latin typeface="IBM Plex Sans"/>
               </a:rPr>
-              <a:t>Real products close this loop by parsing the 835 remittance files</a:t>
-            </a:r>
+              <a:t>Every commercial product here trains on its own private history.</a:t>
+            </a:r>
+          </a:p>
+          <a:p>
+            <a:pPr>
+              <a:spcAft>
+                <a:spcPts val="300"/>
+              </a:spcAft>
+            </a:pPr>
           </a:p>
           <a:p>
             <a:pPr>
@@ -5767,7 +5784,7 @@
                 </a:solidFill>
                 <a:latin typeface="IBM Plex Sans"/>
               </a:rPr>
-              <a:t>insurers return, retraining as outcomes accumulate over weeks.</a:t>
+              <a:t>So we built ours from two real pieces:</a:t>
             </a:r>
           </a:p>
           <a:p>
@@ -5783,15 +5800,8 @@
                 </a:solidFill>
                 <a:latin typeface="IBM Plex Sans"/>
               </a:rPr>
-              <a:t>Nobody in this industry has live self-improvement.</a:t>
-            </a:r>
-          </a:p>
-          <a:p>
-            <a:pPr>
-              <a:spcAft>
-                <a:spcPts val="300"/>
-              </a:spcAft>
-            </a:pPr>
+              <a:t>     Synthea — open clinical simulator, real SNOMED CT codes</a:t>
+            </a:r>
           </a:p>
           <a:p>
             <a:pPr>
@@ -5806,8 +5816,15 @@
                 </a:solidFill>
                 <a:latin typeface="IBM Plex Sans"/>
               </a:rPr>
-              <a:t>Our architecture supports that path. The demo does not pretend to</a:t>
-            </a:r>
+              <a:t>     X12 CARC — the real industry rejection-reason standard</a:t>
+            </a:r>
+          </a:p>
+          <a:p>
+            <a:pPr>
+              <a:spcAft>
+                <a:spcPts val="300"/>
+              </a:spcAft>
+            </a:pPr>
           </a:p>
           <a:p>
             <a:pPr>
@@ -5822,7 +5839,39 @@
                 </a:solidFill>
                 <a:latin typeface="IBM Plex Sans"/>
               </a:rPr>
-              <a:t>have walked it.</a:t>
+              <a:t>Only the labelling logic is ours, and we documented exactly where</a:t>
+            </a:r>
+          </a:p>
+          <a:p>
+            <a:pPr>
+              <a:spcAft>
+                <a:spcPts val="300"/>
+              </a:spcAft>
+            </a:pPr>
+            <a:r>
+              <a:rPr sz="1500">
+                <a:solidFill>
+                  <a:srgbClr val="4A463B"/>
+                </a:solidFill>
+                <a:latin typeface="IBM Plex Sans"/>
+              </a:rPr>
+              <a:t>that line falls. A near-perfect score on self-generated data would</a:t>
+            </a:r>
+          </a:p>
+          <a:p>
+            <a:pPr>
+              <a:spcAft>
+                <a:spcPts val="300"/>
+              </a:spcAft>
+            </a:pPr>
+            <a:r>
+              <a:rPr sz="1500">
+                <a:solidFill>
+                  <a:srgbClr val="4A463B"/>
+                </a:solidFill>
+                <a:latin typeface="IBM Plex Sans"/>
+              </a:rPr>
+              <a:t>only prove the model memorised our own rules.</a:t>
             </a:r>
           </a:p>
         </p:txBody>
@@ -5830,6 +5879,45 @@
       <p:sp>
         <p:nvSpPr>
           <p:cNvPr id="6" name="TextBox 5"/>
+          <p:cNvSpPr txBox="1"/>
+          <p:nvPr/>
+        </p:nvSpPr>
+        <p:spPr>
+          <a:xfrm>
+            <a:off x="822960" y="6035040"/>
+            <a:ext cx="10515600" cy="365760"/>
+          </a:xfrm>
+          <a:prstGeom prst="rect">
+            <a:avLst/>
+          </a:prstGeom>
+          <a:noFill/>
+        </p:spPr>
+        <p:txBody>
+          <a:bodyPr wrap="none">
+            <a:spAutoFit/>
+          </a:bodyPr>
+          <a:lstStyle/>
+          <a:p>
+            <a:pPr algn="l">
+              <a:spcAft>
+                <a:spcPts val="0"/>
+              </a:spcAft>
+            </a:pPr>
+            <a:r>
+              <a:rPr sz="1100" b="0">
+                <a:solidFill>
+                  <a:srgbClr val="7D7767"/>
+                </a:solidFill>
+                <a:latin typeface="IBM Plex Mono"/>
+              </a:rPr>
+              <a:t>docs/data-provenance.md · docs/model-card.md</a:t>
+            </a:r>
+          </a:p>
+        </p:txBody>
+      </p:sp>
+      <p:sp>
+        <p:nvSpPr>
+          <p:cNvPr id="7" name="TextBox 6"/>
           <p:cNvSpPr txBox="1"/>
           <p:nvPr/>
         </p:nvSpPr>
@@ -5926,7 +6014,7 @@
                 </a:solidFill>
                 <a:latin typeface="IBM Plex Mono"/>
               </a:rPr>
-              <a:t>WHAT'S NEXT</a:t>
+              <a:t>THE LOOP</a:t>
             </a:r>
           </a:p>
         </p:txBody>
@@ -5965,7 +6053,7 @@
                 </a:solidFill>
                 <a:latin typeface="Newsreader"/>
               </a:rPr>
-              <a:t>What production would need</a:t>
+              <a:t>Honest about self-improvement</a:t>
             </a:r>
           </a:p>
         </p:txBody>
@@ -6039,7 +6127,7 @@
                 </a:solidFill>
                 <a:latin typeface="IBM Plex Sans"/>
               </a:rPr>
-              <a:t>1.  Real historical claims with real adjudication outcomes, from a</a:t>
+              <a:t>When staff disagree, one click logs the correction as a labelled</a:t>
             </a:r>
           </a:p>
           <a:p>
@@ -6055,8 +6143,15 @@
                 </a:solidFill>
                 <a:latin typeface="IBM Plex Sans"/>
               </a:rPr>
-              <a:t>     partner clinic or TPA</a:t>
-            </a:r>
+              <a:t>example. That is all it does, and we say so.</a:t>
+            </a:r>
+          </a:p>
+          <a:p>
+            <a:pPr>
+              <a:spcAft>
+                <a:spcPts val="300"/>
+              </a:spcAft>
+            </a:pPr>
           </a:p>
           <a:p>
             <a:pPr>
@@ -6071,7 +6166,7 @@
                 </a:solidFill>
                 <a:latin typeface="IBM Plex Sans"/>
               </a:rPr>
-              <a:t>2.  Parsed 835 remittance advice, for the codes insurers actually sent</a:t>
+              <a:t>Real products close this loop by parsing the 835 remittance files</a:t>
             </a:r>
           </a:p>
           <a:p>
@@ -6087,7 +6182,7 @@
                 </a:solidFill>
                 <a:latin typeface="IBM Plex Sans"/>
               </a:rPr>
-              <a:t>3.  Retraining as outcomes accumulate, with human corrections as labels</a:t>
+              <a:t>insurers return, retraining as outcomes accumulate over weeks.</a:t>
             </a:r>
           </a:p>
           <a:p>
@@ -6103,7 +6198,7 @@
                 </a:solidFill>
                 <a:latin typeface="IBM Plex Sans"/>
               </a:rPr>
-              <a:t>4.  Per-insurer models — filing rules and tariffs differ by payer</a:t>
+              <a:t>Nobody in this industry has live self-improvement.</a:t>
             </a:r>
           </a:p>
           <a:p>
@@ -6126,7 +6221,23 @@
                 </a:solidFill>
                 <a:latin typeface="IBM Plex Sans"/>
               </a:rPr>
-              <a:t>The system supports all four. It cannot access the data they need.</a:t>
+              <a:t>Our architecture supports that path. The demo does not pretend to</a:t>
+            </a:r>
+          </a:p>
+          <a:p>
+            <a:pPr>
+              <a:spcAft>
+                <a:spcPts val="300"/>
+              </a:spcAft>
+            </a:pPr>
+            <a:r>
+              <a:rPr sz="1500">
+                <a:solidFill>
+                  <a:srgbClr val="4A463B"/>
+                </a:solidFill>
+                <a:latin typeface="IBM Plex Sans"/>
+              </a:rPr>
+              <a:t>have walked it.</a:t>
             </a:r>
           </a:p>
         </p:txBody>
@@ -6139,8 +6250,8 @@
         </p:nvSpPr>
         <p:spPr>
           <a:xfrm>
-            <a:off x="822960" y="6035040"/>
-            <a:ext cx="10515600" cy="365760"/>
+            <a:off x="11247120" y="6035040"/>
+            <a:ext cx="548640" cy="365760"/>
           </a:xfrm>
           <a:prstGeom prst="rect">
             <a:avLst/>
@@ -6165,21 +6276,47 @@
                 </a:solidFill>
                 <a:latin typeface="IBM Plex Mono"/>
               </a:rPr>
-              <a:t>Python · LightGBM · SHAP · FastAPI · Next.js · Qwen on DashScope · Alibaba Cloud ECS</a:t>
-            </a:r>
-          </a:p>
-        </p:txBody>
-      </p:sp>
-      <p:sp>
-        <p:nvSpPr>
-          <p:cNvPr id="7" name="TextBox 6"/>
+              <a:t>8</a:t>
+            </a:r>
+          </a:p>
+        </p:txBody>
+      </p:sp>
+    </p:spTree>
+  </p:cSld>
+  <p:clrMapOvr>
+    <a:masterClrMapping/>
+  </p:clrMapOvr>
+</p:sld>
+</file>
+
+<file path=ppt/slides/slide9.xml><?xml version="1.0" encoding="utf-8"?>
+<p:sld xmlns:a="http://schemas.openxmlformats.org/drawingml/2006/main" xmlns:p="http://schemas.openxmlformats.org/presentationml/2006/main" xmlns:r="http://schemas.openxmlformats.org/officeDocument/2006/relationships">
+  <p:cSld>
+    <p:bg>
+      <p:bgPr>
+        <a:solidFill>
+          <a:srgbClr val="FAF9F6"/>
+        </a:solidFill>
+        <a:effectLst/>
+      </p:bgPr>
+    </p:bg>
+    <p:spTree>
+      <p:nvGrpSpPr>
+        <p:cNvPr id="1" name=""/>
+        <p:cNvGrpSpPr/>
+        <p:nvPr/>
+      </p:nvGrpSpPr>
+      <p:grpSpPr/>
+      <p:sp>
+        <p:nvSpPr>
+          <p:cNvPr id="2" name="TextBox 1"/>
           <p:cNvSpPr txBox="1"/>
           <p:nvPr/>
         </p:nvSpPr>
         <p:spPr>
           <a:xfrm>
-            <a:off x="11247120" y="6035040"/>
-            <a:ext cx="548640" cy="365760"/>
+            <a:off x="822960" y="594360"/>
+            <a:ext cx="10058400" cy="274320"/>
           </a:xfrm>
           <a:prstGeom prst="rect">
             <a:avLst/>
@@ -6204,7 +6341,285 @@
                 </a:solidFill>
                 <a:latin typeface="IBM Plex Mono"/>
               </a:rPr>
-              <a:t>8</a:t>
+              <a:t>WHAT'S NEXT</a:t>
+            </a:r>
+          </a:p>
+        </p:txBody>
+      </p:sp>
+      <p:sp>
+        <p:nvSpPr>
+          <p:cNvPr id="3" name="TextBox 2"/>
+          <p:cNvSpPr txBox="1"/>
+          <p:nvPr/>
+        </p:nvSpPr>
+        <p:spPr>
+          <a:xfrm>
+            <a:off x="777240" y="960120"/>
+            <a:ext cx="10607040" cy="914400"/>
+          </a:xfrm>
+          <a:prstGeom prst="rect">
+            <a:avLst/>
+          </a:prstGeom>
+          <a:noFill/>
+        </p:spPr>
+        <p:txBody>
+          <a:bodyPr wrap="none">
+            <a:spAutoFit/>
+          </a:bodyPr>
+          <a:lstStyle/>
+          <a:p>
+            <a:pPr algn="l">
+              <a:spcAft>
+                <a:spcPts val="0"/>
+              </a:spcAft>
+            </a:pPr>
+            <a:r>
+              <a:rPr sz="3000" b="0">
+                <a:solidFill>
+                  <a:srgbClr val="17150F"/>
+                </a:solidFill>
+                <a:latin typeface="Newsreader"/>
+              </a:rPr>
+              <a:t>What production would need</a:t>
+            </a:r>
+          </a:p>
+        </p:txBody>
+      </p:sp>
+      <p:cxnSp>
+        <p:nvCxnSpPr>
+          <p:cNvPr id="4" name="Connector 3"/>
+          <p:cNvCxnSpPr/>
+          <p:nvPr/>
+        </p:nvCxnSpPr>
+        <p:spPr>
+          <a:xfrm>
+            <a:off x="822960" y="1965960"/>
+            <a:ext cx="10515600" cy="0"/>
+          </a:xfrm>
+          <a:prstGeom prst="line">
+            <a:avLst/>
+          </a:prstGeom>
+          <a:ln w="9525">
+            <a:solidFill>
+              <a:srgbClr val="E2DED2"/>
+            </a:solidFill>
+          </a:ln>
+        </p:spPr>
+        <p:style>
+          <a:lnRef idx="2">
+            <a:schemeClr val="accent1"/>
+          </a:lnRef>
+          <a:fillRef idx="0">
+            <a:schemeClr val="accent1"/>
+          </a:fillRef>
+          <a:effectRef idx="1">
+            <a:schemeClr val="accent1"/>
+          </a:effectRef>
+          <a:fontRef idx="minor">
+            <a:schemeClr val="tx1"/>
+          </a:fontRef>
+        </p:style>
+      </p:cxnSp>
+      <p:sp>
+        <p:nvSpPr>
+          <p:cNvPr id="5" name="TextBox 4"/>
+          <p:cNvSpPr txBox="1"/>
+          <p:nvPr/>
+        </p:nvSpPr>
+        <p:spPr>
+          <a:xfrm>
+            <a:off x="822960" y="2286000"/>
+            <a:ext cx="6949440" cy="3291840"/>
+          </a:xfrm>
+          <a:prstGeom prst="rect">
+            <a:avLst/>
+          </a:prstGeom>
+          <a:noFill/>
+        </p:spPr>
+        <p:txBody>
+          <a:bodyPr wrap="square">
+            <a:spAutoFit/>
+          </a:bodyPr>
+          <a:lstStyle/>
+          <a:p>
+            <a:pPr>
+              <a:spcAft>
+                <a:spcPts val="300"/>
+              </a:spcAft>
+            </a:pPr>
+            <a:r>
+              <a:rPr sz="1500">
+                <a:solidFill>
+                  <a:srgbClr val="4A463B"/>
+                </a:solidFill>
+                <a:latin typeface="IBM Plex Sans"/>
+              </a:rPr>
+              <a:t>1.  Real historical claims with real adjudication outcomes, from a</a:t>
+            </a:r>
+          </a:p>
+          <a:p>
+            <a:pPr>
+              <a:spcAft>
+                <a:spcPts val="300"/>
+              </a:spcAft>
+            </a:pPr>
+            <a:r>
+              <a:rPr sz="1500">
+                <a:solidFill>
+                  <a:srgbClr val="4A463B"/>
+                </a:solidFill>
+                <a:latin typeface="IBM Plex Sans"/>
+              </a:rPr>
+              <a:t>     partner clinic or TPA</a:t>
+            </a:r>
+          </a:p>
+          <a:p>
+            <a:pPr>
+              <a:spcAft>
+                <a:spcPts val="300"/>
+              </a:spcAft>
+            </a:pPr>
+            <a:r>
+              <a:rPr sz="1500">
+                <a:solidFill>
+                  <a:srgbClr val="4A463B"/>
+                </a:solidFill>
+                <a:latin typeface="IBM Plex Sans"/>
+              </a:rPr>
+              <a:t>2.  Parsed 835 remittance advice, for the codes insurers actually sent</a:t>
+            </a:r>
+          </a:p>
+          <a:p>
+            <a:pPr>
+              <a:spcAft>
+                <a:spcPts val="300"/>
+              </a:spcAft>
+            </a:pPr>
+            <a:r>
+              <a:rPr sz="1500">
+                <a:solidFill>
+                  <a:srgbClr val="4A463B"/>
+                </a:solidFill>
+                <a:latin typeface="IBM Plex Sans"/>
+              </a:rPr>
+              <a:t>3.  Retraining as outcomes accumulate, with human corrections as labels</a:t>
+            </a:r>
+          </a:p>
+          <a:p>
+            <a:pPr>
+              <a:spcAft>
+                <a:spcPts val="300"/>
+              </a:spcAft>
+            </a:pPr>
+            <a:r>
+              <a:rPr sz="1500">
+                <a:solidFill>
+                  <a:srgbClr val="4A463B"/>
+                </a:solidFill>
+                <a:latin typeface="IBM Plex Sans"/>
+              </a:rPr>
+              <a:t>4.  Per-insurer models — filing rules and tariffs differ by payer</a:t>
+            </a:r>
+          </a:p>
+          <a:p>
+            <a:pPr>
+              <a:spcAft>
+                <a:spcPts val="300"/>
+              </a:spcAft>
+            </a:pPr>
+          </a:p>
+          <a:p>
+            <a:pPr>
+              <a:spcAft>
+                <a:spcPts val="300"/>
+              </a:spcAft>
+            </a:pPr>
+            <a:r>
+              <a:rPr sz="1500">
+                <a:solidFill>
+                  <a:srgbClr val="4A463B"/>
+                </a:solidFill>
+                <a:latin typeface="IBM Plex Sans"/>
+              </a:rPr>
+              <a:t>The system supports all four. It cannot access the data they need.</a:t>
+            </a:r>
+          </a:p>
+        </p:txBody>
+      </p:sp>
+      <p:sp>
+        <p:nvSpPr>
+          <p:cNvPr id="6" name="TextBox 5"/>
+          <p:cNvSpPr txBox="1"/>
+          <p:nvPr/>
+        </p:nvSpPr>
+        <p:spPr>
+          <a:xfrm>
+            <a:off x="822960" y="6035040"/>
+            <a:ext cx="10515600" cy="365760"/>
+          </a:xfrm>
+          <a:prstGeom prst="rect">
+            <a:avLst/>
+          </a:prstGeom>
+          <a:noFill/>
+        </p:spPr>
+        <p:txBody>
+          <a:bodyPr wrap="none">
+            <a:spAutoFit/>
+          </a:bodyPr>
+          <a:lstStyle/>
+          <a:p>
+            <a:pPr algn="l">
+              <a:spcAft>
+                <a:spcPts val="0"/>
+              </a:spcAft>
+            </a:pPr>
+            <a:r>
+              <a:rPr sz="1100" b="0">
+                <a:solidFill>
+                  <a:srgbClr val="7D7767"/>
+                </a:solidFill>
+                <a:latin typeface="IBM Plex Mono"/>
+              </a:rPr>
+              <a:t>Python · LightGBM · SHAP · FastAPI · Next.js · Qwen on DashScope · containerised, ECS runbook</a:t>
+            </a:r>
+          </a:p>
+        </p:txBody>
+      </p:sp>
+      <p:sp>
+        <p:nvSpPr>
+          <p:cNvPr id="7" name="TextBox 6"/>
+          <p:cNvSpPr txBox="1"/>
+          <p:nvPr/>
+        </p:nvSpPr>
+        <p:spPr>
+          <a:xfrm>
+            <a:off x="11247120" y="6035040"/>
+            <a:ext cx="548640" cy="365760"/>
+          </a:xfrm>
+          <a:prstGeom prst="rect">
+            <a:avLst/>
+          </a:prstGeom>
+          <a:noFill/>
+        </p:spPr>
+        <p:txBody>
+          <a:bodyPr wrap="none">
+            <a:spAutoFit/>
+          </a:bodyPr>
+          <a:lstStyle/>
+          <a:p>
+            <a:pPr algn="l">
+              <a:spcAft>
+                <a:spcPts val="0"/>
+              </a:spcAft>
+            </a:pPr>
+            <a:r>
+              <a:rPr sz="1100" b="0">
+                <a:solidFill>
+                  <a:srgbClr val="7D7767"/>
+                </a:solidFill>
+                <a:latin typeface="IBM Plex Mono"/>
+              </a:rPr>
+              <a:t>9</a:t>
             </a:r>
           </a:p>
         </p:txBody>

</xml_diff>